<commit_message>
Präsentation: Fokus auf Bewusstsein statt Entscheidungsvorlage
Co-Authored-By: Claude Opus 5.5 <noreply@anthropic.com>
Claude-Session: https://claude.ai/code/session_01JQnYJd487yP9hQqERmmwsD
</commit_message>
<xml_diff>
--- a/praesentation/Fiori_vs_Freestyle.pptx
+++ b/praesentation/Fiori_vs_Freestyle.pptx
@@ -127,19 +127,19 @@
   <p:extLst>
     <p:ext uri="{521415D9-36F7-43E2-AB2F-B90AF26B5E84}">
       <p14:sectionLst xmlns:p14="http://schemas.microsoft.com/office/powerpoint/2010/main">
-        <p14:section name="Einstieg" id="{6df5ab9d-f7e4-d7f1-99bb-25e1a6ed0d30}">
+        <p14:section name="Einstieg" id="{6035d874-c025-2222-1639-0eb330a541c8}">
           <p14:sldIdLst>
             <p14:sldId id="256"/>
             <p14:sldId id="257"/>
             <p14:sldId id="258"/>
           </p14:sldIdLst>
         </p14:section>
-        <p14:section name="Einordnung" id="{840fcced-d8ce-f292-abfc-04618d602e34}">
+        <p14:section name="Einordnung" id="{834af46a-5fae-e54b-945c-7a57d8d6de3c}">
           <p14:sldIdLst>
             <p14:sldId id="259"/>
           </p14:sldIdLst>
         </p14:section>
-        <p14:section name="Demo" id="{6bc710ed-7c03-e66a-ab04-6b481c5bb3b3}">
+        <p14:section name="Demo" id="{db3df99d-91df-0e3a-4c8d-532f4f1028f5}">
           <p14:sldIdLst>
             <p14:sldId id="260"/>
             <p14:sldId id="261"/>
@@ -147,14 +147,14 @@
             <p14:sldId id="263"/>
           </p14:sldIdLst>
         </p14:section>
-        <p14:section name="Bewertung" id="{60d0d377-94d5-9882-01ab-18b568bd1191}">
+        <p14:section name="Bewertung" id="{c6890580-fee5-8822-9802-05ea8a08b159}">
           <p14:sldIdLst>
             <p14:sldId id="264"/>
             <p14:sldId id="265"/>
             <p14:sldId id="266"/>
           </p14:sldIdLst>
         </p14:section>
-        <p14:section name="Shopfloor" id="{cf54d55d-9f68-f938-724c-edc09730dce6}">
+        <p14:section name="Shopfloor" id="{bcd83242-82a0-ea1a-633e-da3d1512476a}">
           <p14:sldIdLst>
             <p14:sldId id="267"/>
             <p14:sldId id="268"/>
@@ -162,7 +162,7 @@
             <p14:sldId id="270"/>
           </p14:sldIdLst>
         </p14:section>
-        <p14:section name="Kombination" id="{bb0be2ab-c136-3ab5-fbea-e2550b0d606f}">
+        <p14:section name="Kombination" id="{f79b7383-a626-08bb-8bb3-d396ccf7d7c7}">
           <p14:sldIdLst>
             <p14:sldId id="271"/>
             <p14:sldId id="272"/>
@@ -170,7 +170,7 @@
             <p14:sldId id="274"/>
           </p14:sldIdLst>
         </p14:section>
-        <p14:section name="Vorschlag" id="{bd69d547-32c8-8536-8e68-d0a889c69c47}">
+        <p14:section name="Fazit" id="{c5103ea9-867a-97e3-1d0b-4990eba44b52}">
           <p14:sldIdLst>
             <p14:sldId id="275"/>
             <p14:sldId id="276"/>
@@ -1845,7 +1845,7 @@
           <a:p>
             <a:r>
               <a:rPr lang="en-US" dirty="0"/>
-              <a:t>So würde ich vorgehen: Erstens prüfen, ob SAP den Ablauf schon im Standard abdeckt. Zweitens das Backend zuerst bauen, als RAP-Business-Objekt mit allen Prüfungen und Aktionen – das ist die Basis für jede Oberfläche. Drittens die Büro-Abläufe mit Fiori Elements, das geht schnell und ohne eigenen UI-Code. Viertens Freestyle gezielt für den einen Ablauf, der es braucht – dünn, ohne eigene Geschäftslogik und gern als eigene Seite in derselben App. Für die Freestyle-Teile gelten feste Spielregeln, damit sie wartbar bleiben.</a:t>
+              <a:t>Ein mögliches Vorgehen, keine Vorschrift: Erstens prüfen, ob SAP den Ablauf schon im Standard abdeckt. Zweitens das Backend zuerst bauen, als RAP-Business-Objekt mit allen Prüfungen und Aktionen – das ist die Basis für jede Oberfläche. Drittens die Büro-Abläufe mit Fiori Elements, das geht schnell und ohne eigenen UI-Code. Viertens Freestyle gezielt für den einen Ablauf, der es braucht – dünn, ohne eigene Geschäftslogik und gern als eigene Seite in derselben App. Unten steht, was die Freestyle-Teile langfristig wartbar hält.</a:t>
             </a:r>
             <a:endParaRPr lang="en-US" dirty="0"/>
           </a:p>
@@ -2021,7 +2021,7 @@
           <a:p>
             <a:r>
               <a:rPr lang="en-US" dirty="0"/>
-              <a:t>Als Leitplanke pro Ablauf, nicht pro Anwendung: Zuerst Fiori Elements mit RAP. Reicht das nicht, erweitern wir Fiori Elements gezielt. Und für klar abgegrenzte Abläufe wie den Scan am Handheld nehmen wir bewusst Freestyle – mit Owner und eingeplantem Wartungsbudget. Die drei Prüffragen können wir in jede Anforderungsklärung aufnehmen.</a:t>
+              <a:t>Das ist als Orientierung gemeint, nicht als Regelwerk – und zwar pro Ablauf, nicht pro Anwendung: Trägt Fiori Elements mit RAP? Reicht eine Erweiterung? Und wo ein Ablauf es wirklich braucht, etwa der Scan am Handheld, ist Freestyle die richtige Wahl – dann aber bewusst, mit eingeplanter Wartung. Die drei Fragen unten helfen, das in jeder Anforderungsklärung kurz zu reflektieren.</a:t>
             </a:r>
             <a:endParaRPr lang="en-US" dirty="0"/>
           </a:p>
@@ -2109,7 +2109,7 @@
           <a:p>
             <a:r>
               <a:rPr lang="en-US" dirty="0"/>
-              <a:t>Zusammenfassung: Gleiches Aussehen heißt nicht gleicher Aufwand. Nicht alles ist SAPUI5, nicht alles ist Fiori Elements – unsere Anwendungen werden Kombinationen sein. Fiori Elements, wo der Standard trägt, Freestyle gezielt dort, wo ein Ablauf es wirklich braucht, zum Beispiel am Handheld. Die Logik gehört ins Backend, damit die Freestyle-Teile klein und wartbar bleiben. Fragen?</a:t>
+              <a:t>Zum Schluss: Ich möchte heute nichts entscheiden lassen. Mir geht es darum, dass wir dasselbe Bild haben. Gleiches Aussehen heißt nicht gleicher Aufwand. Nicht alles ist SAPUI5, nicht alles ist Fiori Elements – unsere Anwendungen werden Kombinationen sein. Und wenn uns jemand – intern oder extern – eine Lösung anbietet, sollten wir einfach nachfragen können: Warum diese Technik, und was bedeutet das für die Wartung? Ich freue mich auf eure Fragen und Erfahrungen.</a:t>
             </a:r>
             <a:endParaRPr lang="en-US" dirty="0"/>
           </a:p>
@@ -2197,7 +2197,7 @@
           <a:p>
             <a:r>
               <a:rPr lang="en-US" dirty="0"/>
-              <a:t>Mir ist wichtig, das klarzustellen: Ich bin weder Gegner noch Verfechter einer Technologie, ich mag SAPUI5 sogar sehr. Es geht darum, dass wir als Unternehmen wissen, was geht und was nicht – und dass wir Angebote von Externen selbst einordnen können. Ein Beispiel: Wenn etwas als Freestyle 5 Personentage kostet und mit Fiori Elements in einem Tag erledigt wäre, ist das schon bei der Erstellung ein Unterschied. Der größere Teil kommt aber danach: Jeder Change Request, jedes Upgrade und die Paketpflege kosten bei Freestyle jedes Jahr wieder. Die Zahlen hier sind eine beispielhafte Größenordnung, keine Messung.</a:t>
+              <a:t>Mir ist wichtig, das gleich am Anfang klarzustellen: Ich will hier nichts verkaufen und auch keine Technologie durchsetzen. Ich bin weder Gegner noch Verfechter, ich mag SAPUI5 sogar sehr. Mir geht es um Bewusstsein: dass wir als Unternehmen wissen, was geht und was nicht, und Angebote – auch von Externen – selbst einordnen können. Ein Beispiel zur Größenordnung: Wenn etwas als Freestyle 5 Personentage kostet und mit Fiori Elements in einem Tag erledigt wäre, ist das schon bei der Erstellung ein Unterschied. Der größere Teil kommt aber danach: Jeder Change Request, jedes Upgrade und die Paketpflege kosten bei Freestyle jedes Jahr wieder. Die Zahlen sind ein Beispiel, keine Messung.</a:t>
             </a:r>
             <a:endParaRPr lang="en-US" dirty="0"/>
           </a:p>
@@ -12700,7 +12700,7 @@
                   <a:schemeClr val="tx2"/>
                 </a:solidFill>
               </a:rPr>
-              <a:t>So setzen wir Kombinationen um</a:t>
+              <a:t>Wie eine Kombination entstehen kann</a:t>
             </a:r>
             <a:endParaRPr lang="en-US" sz="3400" dirty="0"/>
           </a:p>
@@ -13396,7 +13396,7 @@
                   <a:schemeClr val="tx1"/>
                 </a:solidFill>
               </a:rPr>
-              <a:t>Spielregeln für die Freestyle-Teile</a:t>
+              <a:t>Was die Freestyle-Teile wartbar hält</a:t>
             </a:r>
             <a:endParaRPr lang="en-US" sz="1800" dirty="0"/>
           </a:p>
@@ -14325,7 +14325,7 @@
                   <a:schemeClr val="tx2"/>
                 </a:solidFill>
               </a:rPr>
-              <a:t>Leitplanke: die richtige Technik je Ablauf</a:t>
+              <a:t>Orientierung: die passende Technik je Ablauf</a:t>
             </a:r>
             <a:endParaRPr lang="en-US" sz="3400" dirty="0"/>
           </a:p>
@@ -14815,7 +14815,7 @@
                   <a:schemeClr val="tx1"/>
                 </a:solidFill>
               </a:rPr>
-              <a:t>für klar abgegrenzte Abläufe wie Handheld-Scan – mit Owner und Wartungsbudget.</a:t>
+              <a:t>für klar abgegrenzte Abläufe wie Handheld-Scan – mit bewusst eingeplanter Wartung.</a:t>
             </a:r>
             <a:endParaRPr lang="en-US" sz="1500" dirty="0"/>
           </a:p>
@@ -14851,7 +14851,7 @@
                   <a:schemeClr val="tx1"/>
                 </a:solidFill>
               </a:rPr>
-              <a:t>Prüffragen vor jedem Freestyle-Teil</a:t>
+              <a:t>Fragen, die sich vor jedem Freestyle-Teil lohnen</a:t>
             </a:r>
             <a:endParaRPr lang="en-US" sz="1800" dirty="0"/>
           </a:p>
@@ -15105,7 +15105,7 @@
                   <a:schemeClr val="accent6"/>
                 </a:solidFill>
               </a:rPr>
-              <a:t>Die Lösung ist die richtige Kombination, auf einem gemeinsamen Backend.</a:t>
+              <a:t>Es geht nicht um Entweder-oder, sondern um die bewusste Wahl je Ablauf.</a:t>
             </a:r>
             <a:endParaRPr lang="en-US" sz="2200" dirty="0"/>
           </a:p>
@@ -15141,7 +15141,7 @@
                   <a:schemeClr val="bg1"/>
                 </a:solidFill>
               </a:rPr>
-              <a:t>Nächste Schritte</a:t>
+              <a:t>Was ich mitgeben möchte</a:t>
             </a:r>
             <a:endParaRPr lang="en-US" sz="2000" dirty="0"/>
           </a:p>
@@ -15233,7 +15233,7 @@
                   <a:schemeClr val="bg1"/>
                 </a:solidFill>
               </a:rPr>
-              <a:t>Fiori Elements + RAP für Büro- und Standardabläufe</a:t>
+              <a:t>Gleicher Look heißt nicht gleicher Aufwand</a:t>
             </a:r>
             <a:endParaRPr lang="en-US" sz="1500" dirty="0"/>
           </a:p>
@@ -15248,6 +15248,98 @@
         <p:spPr>
           <a:xfrm>
             <a:off x="8138160" y="3108960"/>
+            <a:ext cx="502920" cy="502920"/>
+          </a:xfrm>
+          <a:prstGeom prst="ellipse">
+            <a:avLst/>
+          </a:prstGeom>
+          <a:solidFill>
+            <a:schemeClr val="accent1"/>
+          </a:solidFill>
+          <a:ln/>
+        </p:spPr>
+      </p:sp>
+      <p:sp>
+        <p:nvSpPr>
+          <p:cNvPr id="9" name="Text 7"/>
+          <p:cNvSpPr txBox="1"/>
+          <p:nvPr/>
+        </p:nvSpPr>
+        <p:spPr>
+          <a:xfrm>
+            <a:off x="8138160" y="3108960"/>
+            <a:ext cx="502920" cy="502920"/>
+          </a:xfrm>
+          <a:prstGeom prst="rect">
+            <a:avLst/>
+          </a:prstGeom>
+          <a:noFill/>
+          <a:ln/>
+        </p:spPr>
+        <p:txBody>
+          <a:bodyPr wrap="square" lIns="0" tIns="0" rIns="0" bIns="0" rtlCol="0" anchor="ctr"/>
+          <a:lstStyle/>
+          <a:p>
+            <a:pPr algn="ctr" indent="0" marL="0">
+              <a:buNone/>
+            </a:pPr>
+            <a:r>
+              <a:rPr lang="en-US" sz="1600" b="1" dirty="0">
+                <a:solidFill>
+                  <a:schemeClr val="bg1"/>
+                </a:solidFill>
+              </a:rPr>
+              <a:t>2</a:t>
+            </a:r>
+            <a:endParaRPr lang="en-US" sz="1600" dirty="0"/>
+          </a:p>
+        </p:txBody>
+      </p:sp>
+      <p:sp>
+        <p:nvSpPr>
+          <p:cNvPr id="10" name="Text 8"/>
+          <p:cNvSpPr txBox="1"/>
+          <p:nvPr/>
+        </p:nvSpPr>
+        <p:spPr>
+          <a:xfrm>
+            <a:off x="8823960" y="3063240"/>
+            <a:ext cx="2834640" cy="685800"/>
+          </a:xfrm>
+          <a:prstGeom prst="rect">
+            <a:avLst/>
+          </a:prstGeom>
+          <a:noFill/>
+          <a:ln/>
+        </p:spPr>
+        <p:txBody>
+          <a:bodyPr wrap="square" lIns="0" tIns="0" rIns="0" bIns="0" rtlCol="0" anchor="ctr"/>
+          <a:lstStyle/>
+          <a:p>
+            <a:pPr indent="0" marL="0">
+              <a:buNone/>
+            </a:pPr>
+            <a:r>
+              <a:rPr lang="en-US" sz="1500" dirty="0">
+                <a:solidFill>
+                  <a:schemeClr val="bg1"/>
+                </a:solidFill>
+              </a:rPr>
+              <a:t>Fiori Elements trägt die meisten Standardabläufe</a:t>
+            </a:r>
+            <a:endParaRPr lang="en-US" sz="1500" dirty="0"/>
+          </a:p>
+        </p:txBody>
+      </p:sp>
+      <p:sp>
+        <p:nvSpPr>
+          <p:cNvPr id="11" name="Schritt 3"/>
+          <p:cNvSpPr/>
+          <p:nvPr/>
+        </p:nvSpPr>
+        <p:spPr>
+          <a:xfrm>
+            <a:off x="8138160" y="4023360"/>
             <a:ext cx="502920" cy="502920"/>
           </a:xfrm>
           <a:prstGeom prst="ellipse">
@@ -15261,13 +15353,13 @@
       </p:sp>
       <p:sp>
         <p:nvSpPr>
-          <p:cNvPr id="9" name="Text 7"/>
+          <p:cNvPr id="12" name="Text 10"/>
           <p:cNvSpPr txBox="1"/>
           <p:nvPr/>
         </p:nvSpPr>
         <p:spPr>
           <a:xfrm>
-            <a:off x="8138160" y="3108960"/>
+            <a:off x="8138160" y="4023360"/>
             <a:ext cx="502920" cy="502920"/>
           </a:xfrm>
           <a:prstGeom prst="rect">
@@ -15289,7 +15381,7 @@
                   <a:schemeClr val="bg1"/>
                 </a:solidFill>
               </a:rPr>
-              <a:t>2</a:t>
+              <a:t>3</a:t>
             </a:r>
             <a:endParaRPr lang="en-US" sz="1600" dirty="0"/>
           </a:p>
@@ -15297,13 +15389,13 @@
       </p:sp>
       <p:sp>
         <p:nvSpPr>
-          <p:cNvPr id="10" name="Text 8"/>
+          <p:cNvPr id="13" name="Text 11"/>
           <p:cNvSpPr txBox="1"/>
           <p:nvPr/>
         </p:nvSpPr>
         <p:spPr>
           <a:xfrm>
-            <a:off x="8823960" y="3063240"/>
+            <a:off x="8823960" y="3977640"/>
             <a:ext cx="2834640" cy="685800"/>
           </a:xfrm>
           <a:prstGeom prst="rect">
@@ -15325,7 +15417,7 @@
                   <a:schemeClr val="bg1"/>
                 </a:solidFill>
               </a:rPr>
-              <a:t>Freestyle gezielt für Handheld- und Werker-Abläufe</a:t>
+              <a:t>Freestyle ist richtig, wo ein Ablauf es braucht</a:t>
             </a:r>
             <a:endParaRPr lang="en-US" sz="1500" dirty="0"/>
           </a:p>
@@ -15333,13 +15425,13 @@
       </p:sp>
       <p:sp>
         <p:nvSpPr>
-          <p:cNvPr id="11" name="Schritt 3"/>
+          <p:cNvPr id="14" name="Schritt 4"/>
           <p:cNvSpPr/>
           <p:nvPr/>
         </p:nvSpPr>
         <p:spPr>
           <a:xfrm>
-            <a:off x="8138160" y="4023360"/>
+            <a:off x="8138160" y="4937760"/>
             <a:ext cx="502920" cy="502920"/>
           </a:xfrm>
           <a:prstGeom prst="ellipse">
@@ -15353,80 +15445,8 @@
       </p:sp>
       <p:sp>
         <p:nvSpPr>
-          <p:cNvPr id="12" name="Text 10"/>
+          <p:cNvPr id="15" name="Text 13"/>
           <p:cNvSpPr txBox="1"/>
-          <p:nvPr/>
-        </p:nvSpPr>
-        <p:spPr>
-          <a:xfrm>
-            <a:off x="8138160" y="4023360"/>
-            <a:ext cx="502920" cy="502920"/>
-          </a:xfrm>
-          <a:prstGeom prst="rect">
-            <a:avLst/>
-          </a:prstGeom>
-          <a:noFill/>
-          <a:ln/>
-        </p:spPr>
-        <p:txBody>
-          <a:bodyPr wrap="square" lIns="0" tIns="0" rIns="0" bIns="0" rtlCol="0" anchor="ctr"/>
-          <a:lstStyle/>
-          <a:p>
-            <a:pPr algn="ctr" indent="0" marL="0">
-              <a:buNone/>
-            </a:pPr>
-            <a:r>
-              <a:rPr lang="en-US" sz="1600" b="1" dirty="0">
-                <a:solidFill>
-                  <a:schemeClr val="bg1"/>
-                </a:solidFill>
-              </a:rPr>
-              <a:t>3</a:t>
-            </a:r>
-            <a:endParaRPr lang="en-US" sz="1600" dirty="0"/>
-          </a:p>
-        </p:txBody>
-      </p:sp>
-      <p:sp>
-        <p:nvSpPr>
-          <p:cNvPr id="13" name="Text 11"/>
-          <p:cNvSpPr txBox="1"/>
-          <p:nvPr/>
-        </p:nvSpPr>
-        <p:spPr>
-          <a:xfrm>
-            <a:off x="8823960" y="3977640"/>
-            <a:ext cx="2834640" cy="685800"/>
-          </a:xfrm>
-          <a:prstGeom prst="rect">
-            <a:avLst/>
-          </a:prstGeom>
-          <a:noFill/>
-          <a:ln/>
-        </p:spPr>
-        <p:txBody>
-          <a:bodyPr wrap="square" lIns="0" tIns="0" rIns="0" bIns="0" rtlCol="0" anchor="ctr"/>
-          <a:lstStyle/>
-          <a:p>
-            <a:pPr indent="0" marL="0">
-              <a:buNone/>
-            </a:pPr>
-            <a:r>
-              <a:rPr lang="en-US" sz="1500" dirty="0">
-                <a:solidFill>
-                  <a:schemeClr val="bg1"/>
-                </a:solidFill>
-              </a:rPr>
-              <a:t>Geschäftslogik ins Backend – Oberflächen bleiben schlank</a:t>
-            </a:r>
-            <a:endParaRPr lang="en-US" sz="1500" dirty="0"/>
-          </a:p>
-        </p:txBody>
-      </p:sp>
-      <p:sp>
-        <p:nvSpPr>
-          <p:cNvPr id="14" name="Schritt 4"/>
-          <p:cNvSpPr/>
           <p:nvPr/>
         </p:nvSpPr>
         <p:spPr>
@@ -15434,26 +15454,6 @@
             <a:off x="8138160" y="4937760"/>
             <a:ext cx="502920" cy="502920"/>
           </a:xfrm>
-          <a:prstGeom prst="ellipse">
-            <a:avLst/>
-          </a:prstGeom>
-          <a:solidFill>
-            <a:schemeClr val="accent2"/>
-          </a:solidFill>
-          <a:ln/>
-        </p:spPr>
-      </p:sp>
-      <p:sp>
-        <p:nvSpPr>
-          <p:cNvPr id="15" name="Text 13"/>
-          <p:cNvSpPr txBox="1"/>
-          <p:nvPr/>
-        </p:nvSpPr>
-        <p:spPr>
-          <a:xfrm>
-            <a:off x="8138160" y="4937760"/>
-            <a:ext cx="502920" cy="502920"/>
-          </a:xfrm>
           <a:prstGeom prst="rect">
             <a:avLst/>
           </a:prstGeom>
@@ -15509,7 +15509,7 @@
                   <a:schemeClr val="bg1"/>
                 </a:solidFill>
               </a:rPr>
-              <a:t>Owner und Wartungsbudget je Freestyle-App</a:t>
+              <a:t>Bei Angeboten nachfragen: Warum diese Technik?</a:t>
             </a:r>
             <a:endParaRPr lang="en-US" sz="1500" dirty="0"/>
           </a:p>
@@ -15572,7 +15572,7 @@
                   <a:schemeClr val="tx2"/>
                 </a:solidFill>
               </a:rPr>
-              <a:t>Meine Haltung: bewusst entscheiden</a:t>
+              <a:t>Worum es mir geht: Bewusstsein schaffen</a:t>
             </a:r>
             <a:endParaRPr lang="en-US" sz="3400" dirty="0"/>
           </a:p>
@@ -15713,7 +15713,7 @@
                   <a:schemeClr val="accent6"/>
                 </a:solidFill>
               </a:rPr>
-              <a:t>Aber wir müssen als Unternehmen wissen, was geht und was nicht – und Angebote von Externen selbst beurteilen können, statt sie teuer zu bezahlen.</a:t>
+              <a:t>Ich will nichts verkaufen. Ich will, dass wir als Unternehmen wissen, was geht und was nicht – und Angebote, auch von Externen, selbst einordnen können.</a:t>
             </a:r>
             <a:endParaRPr lang="en-US" sz="1600" dirty="0"/>
           </a:p>

</xml_diff>